<commit_message>
Keep core workshop central and publish optional creative app prompts
</commit_message>
<xml_diff>
--- a/slides/workshop.pptx
+++ b/slides/workshop.pptx
@@ -1357,7 +1357,7 @@
           </a:p>
           <a:p>
             <a:r>
-              <a:t>Announce the challenge now: “If you want an extra challenge, build an app with coding agents during the workshop. The theme is open. Put it on your GitHub, show a working interaction at 12:50, and the audience will choose the winner by a show of hands. The prize is a free CogniPilot stocking cap.” Introduce rumoca_fixed_wing as the lead example; BROWSER_APPS.md has its live link. Participants may extend an existing app or start a new one and should explain their contribution. Core exercises need no agent account or GitHub account. Experienced attendees can begin once their environment is ready and keep building during independent work. Ask for a show of hands for Modelica/JAX/CasADi experience. Today's data are synthetic and the trajectory is open loop.</a:t>
+              <a:t>Announce the challenge now: “Power users: apply Rumoca to a problem you care about. Use your coding agent during downtime and independent work, put the app on your GitHub, and show one working interaction. The prize is a free CogniPilot stocking cap, chosen by an audience hand vote.” The core Modelica → JAX → CasADi exercises remain the main activity and need no agent or GitHub account. Point to APP_PROMPT.md for creative inspiration: an Artemis-inspired launch experience with Three.js visuals, or a flight lab extending rumoca_fixed_wing. These are optional prompts, not assigned projects; no Artemis app is supplied. Encourage participants to choose their own question and design. Full AD-based fixed-wing MPC is ambitious and optional. Entries close at 12:40: collect GitHub link, problem, agent/tool used and elapsed build time with estimates labeled. Up to five ready apps present at 12:50 for 45 seconds each; if more are ready, use a random draw plus a backup, with order drawn too. Selection is not a quality judgment; share all entry links in a gallery. Announce the selection by 12:45. Each demo names the agent and build time, contribution, working interaction and checked result. Ask for a show of hands for Modelica/JAX/CasADi experience. Today's data are synthetic and the trajectory is open loop.</a:t>
             </a:r>
           </a:p>
         </p:txBody>
@@ -1507,7 +1507,7 @@
           </a:p>
           <a:p>
             <a:r>
-              <a:t>Use the first four minutes for participant demos: allow up to four one-minute demos; if more entries arrive, shorten each equally so every entry can be shown. Any app theme is welcome. Each entrant shows a working interaction, their own GitHub repository and their contribution. Reserve the final minute for a show-of-hands vote. Each attendee votes for one entry; count visibly. If tied, run a quick vote between the tied entries; if still tied, draw among them. Award one stocking cap to the winning entry; a team chooses its recipient. If there are no entries, invite a brief question about the fixed-wing example and continue to the closing slide. CHALLENGE.md carries the same rules.</a:t>
+              <a:t>Use up to five 45-second demos, selected by the announced readiness check and random draw if needed. Draw order and a backup in advance. Each entrant shows how Rumoca addresses their chosen problem, one working interaction, their GitHub and contribution, a checked result, and the agent/tool used plus elapsed build time. Label estimated times. Have tabs ready and keep the same limit for everyone. Five demos leave 75 seconds for a show-of-hands vote and award. Each attendee votes for one entry; count visibly. If tied, run a quick vote between the tied entries; if still tied, draw among them. Award one stocking cap to the winning entry; a team chooses its recipient. Share all entry links in a gallery, including those not drawn. If there are no entries, invite a brief question about the fixed-wing example and continue to the closing slide. CHALLENGE.md carries the same rules. Keep the core exercise as the workshop's main focus.</a:t>
             </a:r>
           </a:p>
         </p:txBody>
@@ -11507,7 +11507,7 @@
               </a:defRPr>
             </a:pPr>
             <a:r>
-              <a:t>Extra: create an app with</a:t>
+              <a:t>Apply Rumoca to a problem</a:t>
             </a:r>
           </a:p>
           <a:p>
@@ -11529,7 +11529,7 @@
               </a:defRPr>
             </a:pPr>
             <a:r>
-              <a:t>coding agents</a:t>
+              <a:t>you care about</a:t>
             </a:r>
           </a:p>
         </p:txBody>
@@ -11660,7 +11660,7 @@
               </a:defRPr>
             </a:pPr>
             <a:r>
-              <a:t>Open theme: show your</a:t>
+              <a:t>Optional idea: a Three.js</a:t>
             </a:r>
           </a:p>
           <a:p>
@@ -11682,7 +11682,7 @@
               </a:defRPr>
             </a:pPr>
             <a:r>
-              <a:t>idea on your GitHub</a:t>
+              <a:t>Artemis-style launch</a:t>
             </a:r>
           </a:p>
         </p:txBody>
@@ -11880,7 +11880,7 @@
               </a:defRPr>
             </a:pPr>
             <a:r>
-              <a:t>Start whenever ready · CHALLENGE.md · core needs no agent account</a:t>
+              <a:t>Enter by 12:40 · up to 5 demos · CHALLENGE.md · APP_PROMPT.md</a:t>
             </a:r>
           </a:p>
         </p:txBody>
@@ -12805,7 +12805,7 @@
               </a:defRPr>
             </a:pPr>
             <a:r>
-              <a:t>Show one working interaction and your GitHub repo</a:t>
+              <a:t>Up to 5 demos · 45 seconds each · your GitHub</a:t>
             </a:r>
           </a:p>
         </p:txBody>
@@ -12850,7 +12850,7 @@
               </a:defRPr>
             </a:pPr>
             <a:r>
-              <a:t>Explain your contribution and one result you checked</a:t>
+              <a:t>One checked result · agent used · elapsed build time</a:t>
             </a:r>
           </a:p>
         </p:txBody>
@@ -12940,7 +12940,7 @@
               </a:defRPr>
             </a:pPr>
             <a:r>
-              <a:t>Short participant demos → one show-of-hands vote per person</a:t>
+              <a:t>Random draw if more than 5 ready entries → audience hand vote</a:t>
             </a:r>
           </a:p>
         </p:txBody>

</xml_diff>

<commit_message>
Offer an open experiment challenge and install PDF and Lean editor support
</commit_message>
<xml_diff>
--- a/slides/workshop.pptx
+++ b/slides/workshop.pptx
@@ -684,7 +684,7 @@
           </a:p>
           <a:p>
             <a:r>
-              <a:t>Open the actual live plot and ask participants to explain the sign. The slide plot uses emitted JAX equations and reference parameters; not real flight data. Browser wrapper coasts at level hover, so its numbers differ. Optional kl=.30 then restore .18. Instructor solution is an inheritance override, not a second dynamics implementation. Take two questions. End on time for break.</a:t>
+              <a:t>Open the actual live plot and ask participants to explain the sign. The slide plot uses emitted JAX equations and reference parameters; not real flight data. Browser wrapper coasts at level hover, so its numbers differ. Optional kl=.30 then restore .18. Presenter solution is an inheritance override, not a second dynamics implementation. Take two questions. End on time for break.</a:t>
             </a:r>
           </a:p>
         </p:txBody>
@@ -1209,7 +1209,7 @@
           </a:p>
           <a:p>
             <a:r>
-              <a:t>Ten-minute break. Confirm most pairs have fit outputs. Do not edit the model again after fitting; a source hash will require refitting if it changes. Instructor has successful reference fit and primal trajectory warm start. No Mathlib or extra packages are needed for next exercise.</a:t>
+              <a:t>Ten-minute break. Confirm most pairs have fit outputs. Do not edit the model again after fitting; a source hash will require refitting if it changes. Presenters have successful reference fit and primal trajectory warm start. No Mathlib or extra packages are needed for next exercise.</a:t>
             </a:r>
           </a:p>
         </p:txBody>
@@ -1359,7 +1359,7 @@
           </a:p>
           <a:p>
             <a:r>
-              <a:t>Announce the challenge now: “Power users: apply Rumoca to a problem you care about. Use your coding agent during downtime and independent work, put the app on your GitHub, and show one working interaction. The prize is a free CogniPilot stocking cap, chosen by an audience hand vote.” The core Modelica → JAX → CasADi exercises remain the main activity and need no agent or GitHub account. Point to APP_PROMPT.md for creative inspiration: an Artemis-inspired launch experience with Three.js visuals, or a flight lab extending rumoca_fixed_wing. These are optional prompts, not assigned projects; no Artemis app is supplied. Encourage participants to choose their own question and design. Full AD-based fixed-wing MPC is ambitious and optional. Entries close at 12:40: collect GitHub link, problem, agent/tool used and elapsed build time with estimates labeled. Up to five ready apps present at 12:50 for 45 seconds each; if more are ready, use a random draw plus a backup, with order drawn too. Selection is not a quality judgment; share all entry links in a gallery. Announce the selection by 12:45. Each demo names the agent and build time, contribution, working interaction and checked result. Ask for a show of hands for Modelica/JAX/CasADi experience. Today's data are synthetic and the trajectory is open loop.</a:t>
+              <a:t>Announce the challenge now: “Explore a question you care about with Rumoca. Change an existing model, controller or interactive simulator during downtime. Show the effect and explain one result you checked. The audience favorite wins a free CogniPilot stocking cap.” A new app, WASM build, public GitHub repository, deployment and coding-agent subscription are optional. Power users can work with agents; manual experiments are welcome too. Point to the short experiment prompt in APP_PROMPT.md. An interactive Falcon 9-style landing experience is creative inspiration, not a supplied or qualified rocket starter. Welcome equally small experiments from other domains. Full Three.js apps and AD-based fixed-wing MPC are optional stretches; MPC is ambitious. The core Modelica → JAX → CasADi exercises remain the main activity. Entries close at 12:40: collect name/team, question, starting model/app, original change, tool, elapsed work time and a ready interaction or before/after comparison. A local tab, file or screenshare is enough; public links are voluntary. One entry per participant or team. Up to five ready experiments present at 12:50 for 45 seconds; if more are ready, draw five plus a backup and presentation order. Announce by 12:45. Selection is not a quality judgment. Each demo includes question, change, result, one check, tool used and elapsed time, with estimates labeled. Audience members each vote once by show of hands. Ask for a show of hands for Modelica/JAX/CasADi experience. Today's data are synthetic and the trajectory is open loop.</a:t>
             </a:r>
           </a:p>
         </p:txBody>
@@ -1659,7 +1659,7 @@
           </a:p>
           <a:p>
             <a:r>
-              <a:t>Use up to five 45-second demos, selected by the announced readiness check and random draw if needed. Draw order and a backup in advance. Each entrant shows how Rumoca addresses their chosen problem, one working interaction, their GitHub and contribution, a checked result, and the agent/tool used plus elapsed build time. Label estimated times. Have tabs ready and keep the same limit for everyone. Five demos leave 75 seconds for a show-of-hands vote and award. Each attendee votes for one entry; count visibly. If tied, run a quick vote between the tied entries; if still tied, draw among them. Award one stocking cap to the winning entry; a team chooses its recipient. Share all entry links in a gallery, including those not drawn. If there are no entries, invite a brief question about the fixed-wing example and continue to the closing slide. CHALLENGE.md carries the same rules. Keep the core exercise as the workshop's main focus.</a:t>
+              <a:t>Use up to five 45-second demos, selected by the announced readiness check and random draw if needed. Draw order and a backup in advance. Each entrant shows a question Rumoca helps explore, their original change, a working interaction or before/after comparison, one checked result, tool used and elapsed work time. Local files, browser tabs and screenshares are acceptable; public source links are optional. Manual experiments are welcome; name the agent if used and label estimated times. Have tabs/files ready and use the same limit for everyone. Five demos leave 75 seconds for a hand vote and award. Each attendee votes for one entry; count visibly. If tied, run a quick vote between the tied entries; if still tied, draw among them. Award one stocking cap; a team chooses its recipient. Share voluntary links from all entries, including those not drawn. If no entries are ready, take a brief question and continue. CHALLENGE.md carries the same rules. Keep the core exercise as the workshop's main focus.</a:t>
             </a:r>
           </a:p>
         </p:txBody>
@@ -16419,7 +16419,7 @@
               </a:defRPr>
             </a:pPr>
             <a:r>
-              <a:t>OPEN APP CHALLENGE · DEMOS + AUDIENCE VOTE AT 12:50</a:t>
+              <a:t>OPEN EXPERIMENT CHALLENGE · DEMOS + AUDIENCE VOTE AT 12:50</a:t>
             </a:r>
           </a:p>
         </p:txBody>
@@ -16509,7 +16509,7 @@
               </a:defRPr>
             </a:pPr>
             <a:r>
-              <a:t>Run the core. Build something extra.</a:t>
+              <a:t>Run the core. Explore your own question.</a:t>
             </a:r>
           </a:p>
         </p:txBody>
@@ -16554,7 +16554,7 @@
               </a:defRPr>
             </a:pPr>
             <a:r>
-              <a:t>YOUR PROBLEM. YOUR APP.</a:t>
+              <a:t>YOUR QUESTION. YOUR EXPERIMENT.</a:t>
             </a:r>
           </a:p>
         </p:txBody>
@@ -16689,7 +16689,7 @@
               </a:defRPr>
             </a:pPr>
             <a:r>
-              <a:t>Build with your agent during downtime.</a:t>
+              <a:t>Experiment in a model or simulator.</a:t>
             </a:r>
           </a:p>
         </p:txBody>
@@ -16779,7 +16779,7 @@
               </a:defRPr>
             </a:pPr>
             <a:r>
-              <a:t>Optional idea: a Three.js Artemis-style launch</a:t>
+              <a:t>One change in an existing model or simulator is enough</a:t>
             </a:r>
           </a:p>
         </p:txBody>
@@ -17137,7 +17137,7 @@
               </a:defRPr>
             </a:pPr>
             <a:r>
-              <a:t>Enter by 12:40 · up to 5 demos · CHALLENGE.md · APP_PROMPT.md</a:t>
+              <a:t>Enter by 12:40 · up to 5 demos · CHALLENGE.md · hosting optional</a:t>
             </a:r>
           </a:p>
         </p:txBody>
@@ -21020,7 +21020,7 @@
               </a:defRPr>
             </a:pPr>
             <a:r>
-              <a:t>Show your app. Vote for the cap.</a:t>
+              <a:t>Show your experiment. Vote for the cap.</a:t>
             </a:r>
           </a:p>
         </p:txBody>
@@ -21428,7 +21428,7 @@
               </a:defRPr>
             </a:pPr>
             <a:r>
-              <a:t>Show an interaction + one checked result</a:t>
+              <a:t>Show your change + one checked result</a:t>
             </a:r>
           </a:p>
         </p:txBody>
@@ -21473,7 +21473,7 @@
               </a:defRPr>
             </a:pPr>
             <a:r>
-              <a:t>Name your agent. Share elapsed build time + your GitHub.</a:t>
+              <a:t>Name your tool. Share elapsed work time.</a:t>
             </a:r>
           </a:p>
         </p:txBody>

</xml_diff>

<commit_message>
Correct pitched rotor geometry and pin PDF, Lean and Jinja editor tools
</commit_message>
<xml_diff>
--- a/slides/workshop.pptx
+++ b/slides/workshop.pptx
@@ -534,7 +534,7 @@
           </a:p>
           <a:p>
             <a:r>
-              <a:t>Welcome to Hands-On with Rumoca. Lead with the reason to care: “We want your declared physics to travel into simulation, identification, optimization and verification without silently becoming different models. Today you will take one small Modelica model through simulation, fitting and a constrained flight plan.” Introduce presenters James Goppert and Micah Condie, Purdue University, School of Aeronautics and Astronautics, and the Georgia Tech venue. Point to the QR and ask attendees to keep the participant worksheet open. No aerospace background is required. Welcome models and expertise from other disciplines; the closing slide has concrete ways to join the work. Allow five minutes for arrivals and orientation; announce the optional app challenge on the next slide.</a:t>
+              <a:t>Welcome to Hands-On with Rumoca. Lead with the reason to care: “We want your declared physics to travel into simulation, identification, optimization and verification without silently becoming different models. Today you will take one small Modelica model through simulation, fitting and a constrained flight plan.” Introduce presenters James Goppert and Micah Condie, Purdue University, School of Aeronautics and Astronautics, and the Georgia Tech venue. Point to the QR and ask attendees to keep the participant worksheet open. No aerospace background is required. Welcome models and expertise from other disciplines; the closing slide has concrete ways to join the work. Allow five minutes for arrivals and orientation; announce the optional experiment challenge on the next slide.</a:t>
             </a:r>
           </a:p>
         </p:txBody>
@@ -984,7 +984,7 @@
           </a:p>
           <a:p>
             <a:r>
-              <a:t>Give at least 15 minutes for running the fit, inspecting outputs and individual questions. Participants who finish can return to the app challenge. Reference truth kl=.18 N s/m, kq=.08 N s²/m². Loss roughly 26932→1.073, about 25000×. Read rms_by_state with separate units or noise_scaled_rms; avoid calling mixed-unit legacy RMS metres. Recovery --one-coefficient assumes known kl=.18. Stretch: different initial guess; audit already checks six. Do not use holdout to tune parameters during this exercise. If live fails, label reference plot honestly.</a:t>
+              <a:t>Give at least 15 minutes for running the fit, inspecting outputs and individual questions. Participants who finish can return to the experiment challenge. Reference truth kl=.18 N s/m, kq=.08 N s²/m². Loss roughly 26932→1.073, about 25000×. Read rms_by_state with separate units or noise_scaled_rms; avoid calling mixed-unit legacy RMS metres. Recovery --one-coefficient assumes known kl=.18. Stretch: different initial guess; audit already checks six. Do not use holdout to tune parameters during this exercise. If live fails, label reference plot honestly.</a:t>
             </a:r>
           </a:p>
         </p:txBody>
@@ -12902,7 +12902,7 @@
               </a:defRPr>
             </a:pPr>
             <a:r>
-              <a:t>Fit complete? Continue your app or explore the optional checks.</a:t>
+              <a:t>Fit complete? Continue your experiment or explore the optional checks.</a:t>
             </a:r>
           </a:p>
         </p:txBody>
@@ -34807,8 +34807,8 @@
         </p:blipFill>
         <p:spPr>
           <a:xfrm>
-            <a:off x="4517136" y="2161650"/>
-            <a:ext cx="6967728" cy="2854739"/>
+            <a:off x="4517136" y="2153286"/>
+            <a:ext cx="6967728" cy="2871466"/>
           </a:xfrm>
           <a:prstGeom prst="rect">
             <a:avLst/>

</xml_diff>

<commit_message>
Focus the participant workspace on Session, JAX and CasADi
</commit_message>
<xml_diff>
--- a/slides/workshop.pptx
+++ b/slides/workshop.pptx
@@ -2184,7 +2184,7 @@
           </a:p>
           <a:p>
             <a:r>
-              <a:t>Explain that VS Code is the authoring/LSP path and the playground is browser modeling/simulation. Python 0.10.2 exports JAX and CasADi; deployed browser 0.8.13 is separate. Common Python code performs integration and builds optimization objectives, not another plant. Full language/backends are not certified by this example. The compiler structure is an extension seam for solver specialization and heterogeneous compute. Fast Monte Carlo and RL, native AD or JAX/CasADi/PyTorch integrations, and extensible targets are research directions. Today's core qualifies particular CPU exports; the guide and small Torch target are separate demonstrations, not a general hardware-partitioning or throughput claim.</a:t>
+              <a:t>Explain that VS Code is the authoring/LSP path and the playground is browser modeling/simulation. Python 0.10.2 exports JAX and CasADi; deployed browser 0.8.13 is separate. Open examples/simulate.py and point to rm.Session().load(...) then model.to_jax(); open examples/optimize_casadi.py and point to model.to_casadi(). Python code performs integration and builds optimization objectives, not another plant. Full language/backends are not certified by this example. The compiler structure is an extension seam for solver specialization and heterogeneous compute. Fast Monte Carlo and RL, native AD or JAX/CasADi/PyTorch integrations, and extensible targets are research directions. Today's core qualifies particular CPU exports; the guide and small Torch target are separate demonstrations, not a general hardware-partitioning or throughput claim.</a:t>
             </a:r>
           </a:p>
         </p:txBody>
@@ -2409,7 +2409,7 @@
           </a:p>
           <a:p>
             <a:r>
-              <a:t>Give participants most of these five minutes. Verify extension ID JamesGoppert.rumoca-modelica; choose Modelica language, trust workspace per policy. Show a temporary broken expression then undo for actual syntax diagnostics. Hover, completion and diagnostics passed in real VS Code 1.119.0 hosts on all four supported OS/architecture targets; Codespaces remote hover, completion and diagnostics are qualified separately. Smoke runs all three commands, checks gradient/backend agreement, fits, constraints and outputs. Local measured total about 12 seconds after setup. At 10:35 move to the user-guide showcase; use pair or demo recovery if setup is incomplete. App builders can begin their independent challenge once ready.</a:t>
+              <a:t>Start with the .mo file, not a settings icon. Open models/BrowserFlight.mo, which binds the same Quadrotor plant to level hover thrust, zero torque and initial horizontal speed 6 m/s. Click the lightning-bolt Create Rumoca Scenario icon; the Command Palette fallback is Rumoca: Create Rumoca Scenario. Save the generated rumoca-scenario.…toml beside the model. The selected model is BrowserFlight; inspect the scenario editor and text view. Set source_roots=["."], model.file="BrowserFlight.mo", model.name="BrowserFlight", sim.solver="auto", sim.t_end=8.0 and viewer.mode="results_panel". Save and Run Current Rumoca Scenario. Inspect speed decay and increasing position. Explain that solver and horizon are experiment choices, while Modelica declares physics. The core plant has free inputs; this wrapper defines an experiment. Python later supplies a different prescribed input experiment. Do not compare native coast distances directly to the Python maneuver values. Hover/completion can be checked briefly while opening the model. Let attendees create the TOML themselves; do not paste a prepared scenario first. See WORKSHOP.md for fallback commands and settings. If the editor run is unavailable, use the Python experiment and clearly label that alternate route.</a:t>
             </a:r>
           </a:p>
         </p:txBody>
@@ -6494,7 +6494,7 @@
               </a:defRPr>
             </a:pPr>
             <a:r>
-              <a:t>OPEN THE WORKSHOP</a:t>
+              <a:t>CREATE CORE CODESPACE</a:t>
             </a:r>
           </a:p>
         </p:txBody>
@@ -6648,7 +6648,7 @@
               </a:defRPr>
             </a:pPr>
             <a:r>
-              <a:t>Open the slides ↗</a:t>
+              <a:t>Repository ↗</a:t>
             </a:r>
           </a:p>
         </p:txBody>
@@ -7277,7 +7277,7 @@
               </a:defRPr>
             </a:pPr>
             <a:r>
-              <a:t>$ uv run --frozen python scripts/simulate.py</a:t>
+              <a:t>$ uv run --frozen python examples/simulate.py</a:t>
             </a:r>
           </a:p>
         </p:txBody>
@@ -10428,7 +10428,7 @@
               </a:defRPr>
             </a:pPr>
             <a:r>
-              <a:t>$ uv run --frozen python scripts/fit_drag_jax.py</a:t>
+              <a:t>$ uv run --frozen python examples/fit_drag_jax.py</a:t>
             </a:r>
           </a:p>
         </p:txBody>
@@ -15790,7 +15790,7 @@
               </a:defRPr>
             </a:pPr>
             <a:r>
-              <a:t>$ uv run --frozen python scripts/optimize_casadi.py</a:t>
+              <a:t>$ uv run --frozen python examples/optimize_casadi.py</a:t>
             </a:r>
           </a:p>
         </p:txBody>
@@ -18012,7 +18012,7 @@
         <p:spPr>
           <a:xfrm>
             <a:off x="594360" y="6432804"/>
-            <a:ext cx="2596896" cy="365760"/>
+            <a:ext cx="1694688" cy="365760"/>
           </a:xfrm>
           <a:prstGeom prst="roundRect">
             <a:avLst>
@@ -18045,30 +18045,30 @@
         <p:spPr>
           <a:xfrm>
             <a:off x="704088" y="6469380"/>
-            <a:ext cx="2432304" cy="332740"/>
-          </a:xfrm>
-          <a:prstGeom prst="rect">
-            <a:avLst/>
-          </a:prstGeom>
-          <a:noFill/>
-        </p:spPr>
-        <p:txBody>
-          <a:bodyPr wrap="none" lIns="0" rIns="0" tIns="0" bIns="0">
-            <a:spAutoFit/>
-          </a:bodyPr>
-          <a:lstStyle/>
-          <a:p>
-            <a:pPr>
-              <a:lnSpc>
-                <a:spcPct val="124000"/>
-              </a:lnSpc>
-              <a:spcBef>
-                <a:spcPts val="0"/>
-              </a:spcBef>
-              <a:spcAft>
-                <a:spcPts val="0"/>
-              </a:spcAft>
-              <a:defRPr sz="1300" b="1">
+            <a:ext cx="1530096" cy="296901"/>
+          </a:xfrm>
+          <a:prstGeom prst="rect">
+            <a:avLst/>
+          </a:prstGeom>
+          <a:noFill/>
+        </p:spPr>
+        <p:txBody>
+          <a:bodyPr wrap="none" lIns="0" rIns="0" tIns="0" bIns="0">
+            <a:spAutoFit/>
+          </a:bodyPr>
+          <a:lstStyle/>
+          <a:p>
+            <a:pPr>
+              <a:lnSpc>
+                <a:spcPct val="124000"/>
+              </a:lnSpc>
+              <a:spcBef>
+                <a:spcPts val="0"/>
+              </a:spcBef>
+              <a:spcAft>
+                <a:spcPts val="0"/>
+              </a:spcAft>
+              <a:defRPr sz="1072" b="1">
                 <a:solidFill>
                   <a:srgbClr val="FFFFFF"/>
                 </a:solidFill>
@@ -18076,7 +18076,7 @@
               </a:defRPr>
             </a:pPr>
             <a:r>
-              <a:t>Fixed-wing app ↗</a:t>
+              <a:t>Fixed-wing demo ↗</a:t>
             </a:r>
           </a:p>
         </p:txBody>
@@ -18091,8 +18091,8 @@
         </p:nvSpPr>
         <p:spPr>
           <a:xfrm>
-            <a:off x="3300984" y="6432804"/>
-            <a:ext cx="2596896" cy="365760"/>
+            <a:off x="2398776" y="6432804"/>
+            <a:ext cx="1694688" cy="365760"/>
           </a:xfrm>
           <a:prstGeom prst="roundRect">
             <a:avLst>
@@ -18124,31 +18124,31 @@
         </p:nvSpPr>
         <p:spPr>
           <a:xfrm>
-            <a:off x="3410712" y="6469380"/>
-            <a:ext cx="2432304" cy="332740"/>
-          </a:xfrm>
-          <a:prstGeom prst="rect">
-            <a:avLst/>
-          </a:prstGeom>
-          <a:noFill/>
-        </p:spPr>
-        <p:txBody>
-          <a:bodyPr wrap="none" lIns="0" rIns="0" tIns="0" bIns="0">
-            <a:spAutoFit/>
-          </a:bodyPr>
-          <a:lstStyle/>
-          <a:p>
-            <a:pPr>
-              <a:lnSpc>
-                <a:spcPct val="124000"/>
-              </a:lnSpc>
-              <a:spcBef>
-                <a:spcPts val="0"/>
-              </a:spcBef>
-              <a:spcAft>
-                <a:spcPts val="0"/>
-              </a:spcAft>
-              <a:defRPr sz="1300" b="1">
+            <a:off x="2508504" y="6469380"/>
+            <a:ext cx="1530096" cy="304208"/>
+          </a:xfrm>
+          <a:prstGeom prst="rect">
+            <a:avLst/>
+          </a:prstGeom>
+          <a:noFill/>
+        </p:spPr>
+        <p:txBody>
+          <a:bodyPr wrap="none" lIns="0" rIns="0" tIns="0" bIns="0">
+            <a:spAutoFit/>
+          </a:bodyPr>
+          <a:lstStyle/>
+          <a:p>
+            <a:pPr>
+              <a:lnSpc>
+                <a:spcPct val="124000"/>
+              </a:lnSpc>
+              <a:spcBef>
+                <a:spcPts val="0"/>
+              </a:spcBef>
+              <a:spcAft>
+                <a:spcPts val="0"/>
+              </a:spcAft>
+              <a:defRPr sz="1118" b="1">
                 <a:solidFill>
                   <a:srgbClr val="FFFFFF"/>
                 </a:solidFill>
@@ -18156,7 +18156,7 @@
               </a:defRPr>
             </a:pPr>
             <a:r>
-              <a:t>SLAM (in dev) ↗</a:t>
+              <a:t>Fixed-wing code ↗</a:t>
             </a:r>
           </a:p>
         </p:txBody>
@@ -18171,8 +18171,8 @@
         </p:nvSpPr>
         <p:spPr>
           <a:xfrm>
-            <a:off x="6007608" y="6432804"/>
-            <a:ext cx="2596896" cy="365760"/>
+            <a:off x="4203192" y="6432804"/>
+            <a:ext cx="1694688" cy="365760"/>
           </a:xfrm>
           <a:prstGeom prst="roundRect">
             <a:avLst>
@@ -18204,8 +18204,8 @@
         </p:nvSpPr>
         <p:spPr>
           <a:xfrm>
-            <a:off x="6117336" y="6469380"/>
-            <a:ext cx="2432304" cy="332740"/>
+            <a:off x="4312920" y="6469380"/>
+            <a:ext cx="1530096" cy="332740"/>
           </a:xfrm>
           <a:prstGeom prst="rect">
             <a:avLst/>
@@ -18236,7 +18236,7 @@
               </a:defRPr>
             </a:pPr>
             <a:r>
-              <a:t>Mocap viewer ↗</a:t>
+              <a:t>Mocap demo ↗</a:t>
             </a:r>
           </a:p>
         </p:txBody>
@@ -18251,8 +18251,8 @@
         </p:nvSpPr>
         <p:spPr>
           <a:xfrm>
-            <a:off x="8714232" y="6432804"/>
-            <a:ext cx="2596896" cy="365760"/>
+            <a:off x="6007608" y="6432804"/>
+            <a:ext cx="1694688" cy="365760"/>
           </a:xfrm>
           <a:prstGeom prst="roundRect">
             <a:avLst>
@@ -18284,8 +18284,8 @@
         </p:nvSpPr>
         <p:spPr>
           <a:xfrm>
-            <a:off x="8823960" y="6469380"/>
-            <a:ext cx="2432304" cy="332740"/>
+            <a:off x="6117336" y="6469380"/>
+            <a:ext cx="1530096" cy="332740"/>
           </a:xfrm>
           <a:prstGeom prst="rect">
             <a:avLst/>
@@ -18316,14 +18316,174 @@
               </a:defRPr>
             </a:pPr>
             <a:r>
-              <a:t>App guide ↗</a:t>
-            </a:r>
-          </a:p>
-        </p:txBody>
-      </p:sp>
-      <p:sp>
-        <p:nvSpPr>
-          <p:cNvPr id="29" name="TextBox 28"/>
+              <a:t>Mocap code ↗</a:t>
+            </a:r>
+          </a:p>
+        </p:txBody>
+      </p:sp>
+      <p:sp>
+        <p:nvSpPr>
+          <p:cNvPr id="29" name="Rounded Rectangle 28">
+            <a:hlinkClick r:id="rId7"/>
+          </p:cNvPr>
+          <p:cNvSpPr/>
+          <p:nvPr/>
+        </p:nvSpPr>
+        <p:spPr>
+          <a:xfrm>
+            <a:off x="7812024" y="6432804"/>
+            <a:ext cx="1694688" cy="365760"/>
+          </a:xfrm>
+          <a:prstGeom prst="roundRect">
+            <a:avLst>
+              <a:gd name="adj" fmla="val 8000"/>
+            </a:avLst>
+          </a:prstGeom>
+          <a:solidFill>
+            <a:srgbClr val="007E87"/>
+          </a:solidFill>
+          <a:ln>
+            <a:noFill/>
+          </a:ln>
+        </p:spPr>
+        <p:txBody>
+          <a:bodyPr rtlCol="0" anchor="ctr"/>
+          <a:lstStyle/>
+          <a:p>
+            <a:pPr algn="ctr"/>
+          </a:p>
+        </p:txBody>
+      </p:sp>
+      <p:sp>
+        <p:nvSpPr>
+          <p:cNvPr id="30" name="TextBox 29">
+            <a:hlinkClick r:id="rId7"/>
+          </p:cNvPr>
+          <p:cNvSpPr txBox="1"/>
+          <p:nvPr/>
+        </p:nvSpPr>
+        <p:spPr>
+          <a:xfrm>
+            <a:off x="7921752" y="6469380"/>
+            <a:ext cx="1530096" cy="330742"/>
+          </a:xfrm>
+          <a:prstGeom prst="rect">
+            <a:avLst/>
+          </a:prstGeom>
+          <a:noFill/>
+        </p:spPr>
+        <p:txBody>
+          <a:bodyPr wrap="none" lIns="0" rIns="0" tIns="0" bIns="0">
+            <a:spAutoFit/>
+          </a:bodyPr>
+          <a:lstStyle/>
+          <a:p>
+            <a:pPr>
+              <a:lnSpc>
+                <a:spcPct val="124000"/>
+              </a:lnSpc>
+              <a:spcBef>
+                <a:spcPts val="0"/>
+              </a:spcBef>
+              <a:spcAft>
+                <a:spcPts val="0"/>
+              </a:spcAft>
+              <a:defRPr sz="1287" b="1">
+                <a:solidFill>
+                  <a:srgbClr val="FFFFFF"/>
+                </a:solidFill>
+                <a:latin typeface="DejaVu Sans"/>
+              </a:defRPr>
+            </a:pPr>
+            <a:r>
+              <a:t>SLAM (in dev) ↗</a:t>
+            </a:r>
+          </a:p>
+        </p:txBody>
+      </p:sp>
+      <p:sp>
+        <p:nvSpPr>
+          <p:cNvPr id="31" name="Rounded Rectangle 30">
+            <a:hlinkClick r:id="rId8"/>
+          </p:cNvPr>
+          <p:cNvSpPr/>
+          <p:nvPr/>
+        </p:nvSpPr>
+        <p:spPr>
+          <a:xfrm>
+            <a:off x="9616440" y="6432804"/>
+            <a:ext cx="1694688" cy="365760"/>
+          </a:xfrm>
+          <a:prstGeom prst="roundRect">
+            <a:avLst>
+              <a:gd name="adj" fmla="val 8000"/>
+            </a:avLst>
+          </a:prstGeom>
+          <a:solidFill>
+            <a:srgbClr val="007E87"/>
+          </a:solidFill>
+          <a:ln>
+            <a:noFill/>
+          </a:ln>
+        </p:spPr>
+        <p:txBody>
+          <a:bodyPr rtlCol="0" anchor="ctr"/>
+          <a:lstStyle/>
+          <a:p>
+            <a:pPr algn="ctr"/>
+          </a:p>
+        </p:txBody>
+      </p:sp>
+      <p:sp>
+        <p:nvSpPr>
+          <p:cNvPr id="32" name="TextBox 31">
+            <a:hlinkClick r:id="rId8"/>
+          </p:cNvPr>
+          <p:cNvSpPr txBox="1"/>
+          <p:nvPr/>
+        </p:nvSpPr>
+        <p:spPr>
+          <a:xfrm>
+            <a:off x="9726168" y="6469380"/>
+            <a:ext cx="1530096" cy="332740"/>
+          </a:xfrm>
+          <a:prstGeom prst="rect">
+            <a:avLst/>
+          </a:prstGeom>
+          <a:noFill/>
+        </p:spPr>
+        <p:txBody>
+          <a:bodyPr wrap="none" lIns="0" rIns="0" tIns="0" bIns="0">
+            <a:spAutoFit/>
+          </a:bodyPr>
+          <a:lstStyle/>
+          <a:p>
+            <a:pPr>
+              <a:lnSpc>
+                <a:spcPct val="124000"/>
+              </a:lnSpc>
+              <a:spcBef>
+                <a:spcPts val="0"/>
+              </a:spcBef>
+              <a:spcAft>
+                <a:spcPts val="0"/>
+              </a:spcAft>
+              <a:defRPr sz="1300" b="1">
+                <a:solidFill>
+                  <a:srgbClr val="FFFFFF"/>
+                </a:solidFill>
+                <a:latin typeface="DejaVu Sans"/>
+              </a:defRPr>
+            </a:pPr>
+            <a:r>
+              <a:t>SLAM code ↗</a:t>
+            </a:r>
+          </a:p>
+        </p:txBody>
+      </p:sp>
+      <p:sp>
+        <p:nvSpPr>
+          <p:cNvPr id="33" name="TextBox 32"/>
           <p:cNvSpPr txBox="1"/>
           <p:nvPr/>
         </p:nvSpPr>
@@ -28485,7 +28645,7 @@
               </a:defRPr>
             </a:pPr>
             <a:r>
-              <a:t>HANDS-ON · RELEASED LSP VERIFIED ON FOUR PLATFORMS</a:t>
+              <a:t>VS CODE · LIGHTNING BOLT CREATES THE TOML</a:t>
             </a:r>
           </a:p>
         </p:txBody>
@@ -28575,7 +28735,7 @@
               </a:defRPr>
             </a:pPr>
             <a:r>
-              <a:t>Edit with feedback. Check the pipeline.</a:t>
+              <a:t>Configure the experiment, then run it</a:t>
             </a:r>
           </a:p>
         </p:txBody>
@@ -28588,107 +28748,7 @@
         </p:nvSpPr>
         <p:spPr>
           <a:xfrm>
-            <a:off x="4407408" y="1554480"/>
-            <a:ext cx="7187184" cy="3858768"/>
-          </a:xfrm>
-          <a:prstGeom prst="roundRect">
-            <a:avLst>
-              <a:gd name="adj" fmla="val 8000"/>
-            </a:avLst>
-          </a:prstGeom>
-          <a:solidFill>
-            <a:srgbClr val="FFFFFF"/>
-          </a:solidFill>
-          <a:ln>
-            <a:noFill/>
-          </a:ln>
-        </p:spPr>
-        <p:txBody>
-          <a:bodyPr rtlCol="0" anchor="ctr"/>
-          <a:lstStyle/>
-          <a:p>
-            <a:pPr algn="ctr"/>
-          </a:p>
-        </p:txBody>
-      </p:sp>
-      <p:pic>
-        <p:nvPicPr>
-          <p:cNvPr id="8" name="Picture 7" descr="vscode-quadrotor.png"/>
-          <p:cNvPicPr>
-            <a:picLocks noChangeAspect="1"/>
-          </p:cNvPicPr>
-          <p:nvPr/>
-        </p:nvPicPr>
-        <p:blipFill>
-          <a:blip r:embed="rId2"/>
-          <a:stretch>
-            <a:fillRect/>
-          </a:stretch>
-        </p:blipFill>
-        <p:spPr>
-          <a:xfrm>
-            <a:off x="5104180" y="1673351"/>
-            <a:ext cx="5793638" cy="3621024"/>
-          </a:xfrm>
-          <a:prstGeom prst="rect">
-            <a:avLst/>
-          </a:prstGeom>
-        </p:spPr>
-      </p:pic>
-      <p:sp>
-        <p:nvSpPr>
-          <p:cNvPr id="9" name="TextBox 8"/>
-          <p:cNvSpPr txBox="1"/>
-          <p:nvPr/>
-        </p:nvSpPr>
-        <p:spPr>
-          <a:xfrm>
-            <a:off x="640080" y="1700784"/>
-            <a:ext cx="3712463" cy="301244"/>
-          </a:xfrm>
-          <a:prstGeom prst="rect">
-            <a:avLst/>
-          </a:prstGeom>
-          <a:noFill/>
-        </p:spPr>
-        <p:txBody>
-          <a:bodyPr wrap="none" lIns="0" rIns="0" tIns="0" bIns="0">
-            <a:spAutoFit/>
-          </a:bodyPr>
-          <a:lstStyle/>
-          <a:p>
-            <a:pPr>
-              <a:lnSpc>
-                <a:spcPct val="124000"/>
-              </a:lnSpc>
-              <a:spcBef>
-                <a:spcPts val="0"/>
-              </a:spcBef>
-              <a:spcAft>
-                <a:spcPts val="0"/>
-              </a:spcAft>
-              <a:defRPr sz="1100" b="1">
-                <a:solidFill>
-                  <a:srgbClr val="007E87"/>
-                </a:solidFill>
-                <a:latin typeface="DejaVu Sans"/>
-              </a:defRPr>
-            </a:pPr>
-            <a:r>
-              <a:t>TRY THIS</a:t>
-            </a:r>
-          </a:p>
-        </p:txBody>
-      </p:sp>
-      <p:sp>
-        <p:nvSpPr>
-          <p:cNvPr id="10" name="Rounded Rectangle 9"/>
-          <p:cNvSpPr/>
-          <p:nvPr/>
-        </p:nvSpPr>
-        <p:spPr>
-          <a:xfrm>
-            <a:off x="640080" y="2171700"/>
+            <a:off x="640080" y="1924812"/>
             <a:ext cx="338328" cy="338328"/>
           </a:xfrm>
           <a:prstGeom prst="roundRect">
@@ -28713,13 +28773,13 @@
       </p:sp>
       <p:sp>
         <p:nvSpPr>
-          <p:cNvPr id="11" name="TextBox 10"/>
-          <p:cNvSpPr txBox="1"/>
-          <p:nvPr/>
-        </p:nvSpPr>
-        <p:spPr>
-          <a:xfrm>
-            <a:off x="736092" y="2199132"/>
+          <p:cNvPr id="8" name="TextBox 7"/>
+          <p:cNvSpPr txBox="1"/>
+          <p:nvPr/>
+        </p:nvSpPr>
+        <p:spPr>
+          <a:xfrm>
+            <a:off x="736092" y="1952244"/>
             <a:ext cx="237744" cy="348488"/>
           </a:xfrm>
           <a:prstGeom prst="rect">
@@ -28758,37 +28818,37 @@
       </p:sp>
       <p:sp>
         <p:nvSpPr>
-          <p:cNvPr id="12" name="TextBox 11"/>
-          <p:cNvSpPr txBox="1"/>
-          <p:nvPr/>
-        </p:nvSpPr>
-        <p:spPr>
-          <a:xfrm>
-            <a:off x="1143000" y="2148840"/>
-            <a:ext cx="3054096" cy="820927"/>
-          </a:xfrm>
-          <a:prstGeom prst="rect">
-            <a:avLst/>
-          </a:prstGeom>
-          <a:noFill/>
-        </p:spPr>
-        <p:txBody>
-          <a:bodyPr wrap="none" lIns="0" rIns="0" tIns="0" bIns="0">
-            <a:spAutoFit/>
-          </a:bodyPr>
-          <a:lstStyle/>
-          <a:p>
-            <a:pPr>
-              <a:lnSpc>
-                <a:spcPct val="124000"/>
-              </a:lnSpc>
-              <a:spcBef>
-                <a:spcPts val="0"/>
-              </a:spcBef>
-              <a:spcAft>
-                <a:spcPts val="0"/>
-              </a:spcAft>
-              <a:defRPr sz="2200" b="0">
+          <p:cNvPr id="9" name="TextBox 8"/>
+          <p:cNvSpPr txBox="1"/>
+          <p:nvPr/>
+        </p:nvSpPr>
+        <p:spPr>
+          <a:xfrm>
+            <a:off x="1143000" y="1901952"/>
+            <a:ext cx="10387584" cy="584707"/>
+          </a:xfrm>
+          <a:prstGeom prst="rect">
+            <a:avLst/>
+          </a:prstGeom>
+          <a:noFill/>
+        </p:spPr>
+        <p:txBody>
+          <a:bodyPr wrap="none" lIns="0" rIns="0" tIns="0" bIns="0">
+            <a:spAutoFit/>
+          </a:bodyPr>
+          <a:lstStyle/>
+          <a:p>
+            <a:pPr>
+              <a:lnSpc>
+                <a:spcPct val="124000"/>
+              </a:lnSpc>
+              <a:spcBef>
+                <a:spcPts val="0"/>
+              </a:spcBef>
+              <a:spcAft>
+                <a:spcPts val="0"/>
+              </a:spcAft>
+              <a:defRPr sz="2900" b="0">
                 <a:solidFill>
                   <a:srgbClr val="131D2A"/>
                 </a:solidFill>
@@ -28796,42 +28856,20 @@
               </a:defRPr>
             </a:pPr>
             <a:r>
-              <a:t>Open Quadrotor.mo</a:t>
-            </a:r>
-          </a:p>
-          <a:p>
-            <a:pPr>
-              <a:lnSpc>
-                <a:spcPct val="124000"/>
-              </a:lnSpc>
-              <a:spcBef>
-                <a:spcPts val="0"/>
-              </a:spcBef>
-              <a:spcAft>
-                <a:spcPts val="0"/>
-              </a:spcAft>
-              <a:defRPr sz="2200" b="0">
-                <a:solidFill>
-                  <a:srgbClr val="131D2A"/>
-                </a:solidFill>
-                <a:latin typeface="DejaVu Sans"/>
-              </a:defRPr>
-            </a:pPr>
-            <a:r>
-              <a:t>in models/</a:t>
-            </a:r>
-          </a:p>
-        </p:txBody>
-      </p:sp>
-      <p:sp>
-        <p:nvSpPr>
-          <p:cNvPr id="13" name="Rounded Rectangle 12"/>
+              <a:t>Open BrowserFlight.mo → click the lightning bolt</a:t>
+            </a:r>
+          </a:p>
+        </p:txBody>
+      </p:sp>
+      <p:sp>
+        <p:nvSpPr>
+          <p:cNvPr id="10" name="Rounded Rectangle 9"/>
           <p:cNvSpPr/>
           <p:nvPr/>
         </p:nvSpPr>
         <p:spPr>
           <a:xfrm>
-            <a:off x="640080" y="3266948"/>
+            <a:off x="640080" y="2921000"/>
             <a:ext cx="338328" cy="338328"/>
           </a:xfrm>
           <a:prstGeom prst="roundRect">
@@ -28856,13 +28894,13 @@
       </p:sp>
       <p:sp>
         <p:nvSpPr>
-          <p:cNvPr id="14" name="TextBox 13"/>
-          <p:cNvSpPr txBox="1"/>
-          <p:nvPr/>
-        </p:nvSpPr>
-        <p:spPr>
-          <a:xfrm>
-            <a:off x="736092" y="3294380"/>
+          <p:cNvPr id="11" name="TextBox 10"/>
+          <p:cNvSpPr txBox="1"/>
+          <p:nvPr/>
+        </p:nvSpPr>
+        <p:spPr>
+          <a:xfrm>
+            <a:off x="736092" y="2948432"/>
             <a:ext cx="237744" cy="348488"/>
           </a:xfrm>
           <a:prstGeom prst="rect">
@@ -28901,37 +28939,37 @@
       </p:sp>
       <p:sp>
         <p:nvSpPr>
-          <p:cNvPr id="15" name="TextBox 14"/>
-          <p:cNvSpPr txBox="1"/>
-          <p:nvPr/>
-        </p:nvSpPr>
-        <p:spPr>
-          <a:xfrm>
-            <a:off x="1143000" y="3244088"/>
-            <a:ext cx="3054096" cy="820927"/>
-          </a:xfrm>
-          <a:prstGeom prst="rect">
-            <a:avLst/>
-          </a:prstGeom>
-          <a:noFill/>
-        </p:spPr>
-        <p:txBody>
-          <a:bodyPr wrap="none" lIns="0" rIns="0" tIns="0" bIns="0">
-            <a:spAutoFit/>
-          </a:bodyPr>
-          <a:lstStyle/>
-          <a:p>
-            <a:pPr>
-              <a:lnSpc>
-                <a:spcPct val="124000"/>
-              </a:lnSpc>
-              <a:spcBef>
-                <a:spcPts val="0"/>
-              </a:spcBef>
-              <a:spcAft>
-                <a:spcPts val="0"/>
-              </a:spcAft>
-              <a:defRPr sz="2200" b="0">
+          <p:cNvPr id="12" name="TextBox 11"/>
+          <p:cNvSpPr txBox="1"/>
+          <p:nvPr/>
+        </p:nvSpPr>
+        <p:spPr>
+          <a:xfrm>
+            <a:off x="1143000" y="2898140"/>
+            <a:ext cx="10387584" cy="1041400"/>
+          </a:xfrm>
+          <a:prstGeom prst="rect">
+            <a:avLst/>
+          </a:prstGeom>
+          <a:noFill/>
+        </p:spPr>
+        <p:txBody>
+          <a:bodyPr wrap="none" lIns="0" rIns="0" tIns="0" bIns="0">
+            <a:spAutoFit/>
+          </a:bodyPr>
+          <a:lstStyle/>
+          <a:p>
+            <a:pPr>
+              <a:lnSpc>
+                <a:spcPct val="124000"/>
+              </a:lnSpc>
+              <a:spcBef>
+                <a:spcPts val="0"/>
+              </a:spcBef>
+              <a:spcAft>
+                <a:spcPts val="0"/>
+              </a:spcAft>
+              <a:defRPr sz="2900" b="0">
                 <a:solidFill>
                   <a:srgbClr val="131D2A"/>
                 </a:solidFill>
@@ -28939,21 +28977,21 @@
               </a:defRPr>
             </a:pPr>
             <a:r>
-              <a:t>Hover m; try sin</a:t>
-            </a:r>
-          </a:p>
-          <a:p>
-            <a:pPr>
-              <a:lnSpc>
-                <a:spcPct val="124000"/>
-              </a:lnSpc>
-              <a:spcBef>
-                <a:spcPts val="0"/>
-              </a:spcBef>
-              <a:spcAft>
-                <a:spcPts val="0"/>
-              </a:spcAft>
-              <a:defRPr sz="2200" b="0">
+              <a:t>Save scenario TOML → model, source roots, solver, end</a:t>
+            </a:r>
+          </a:p>
+          <a:p>
+            <a:pPr>
+              <a:lnSpc>
+                <a:spcPct val="124000"/>
+              </a:lnSpc>
+              <a:spcBef>
+                <a:spcPts val="0"/>
+              </a:spcBef>
+              <a:spcAft>
+                <a:spcPts val="0"/>
+              </a:spcAft>
+              <a:defRPr sz="2900" b="0">
                 <a:solidFill>
                   <a:srgbClr val="131D2A"/>
                 </a:solidFill>
@@ -28961,20 +28999,20 @@
               </a:defRPr>
             </a:pPr>
             <a:r>
-              <a:t>completion</a:t>
-            </a:r>
-          </a:p>
-        </p:txBody>
-      </p:sp>
-      <p:sp>
-        <p:nvSpPr>
-          <p:cNvPr id="16" name="Rounded Rectangle 15"/>
+              <a:t>time</a:t>
+            </a:r>
+          </a:p>
+        </p:txBody>
+      </p:sp>
+      <p:sp>
+        <p:nvSpPr>
+          <p:cNvPr id="13" name="Rounded Rectangle 12"/>
           <p:cNvSpPr/>
           <p:nvPr/>
         </p:nvSpPr>
         <p:spPr>
           <a:xfrm>
-            <a:off x="640080" y="4362196"/>
+            <a:off x="640080" y="4373880"/>
             <a:ext cx="338328" cy="338328"/>
           </a:xfrm>
           <a:prstGeom prst="roundRect">
@@ -28999,13 +29037,13 @@
       </p:sp>
       <p:sp>
         <p:nvSpPr>
-          <p:cNvPr id="17" name="TextBox 16"/>
-          <p:cNvSpPr txBox="1"/>
-          <p:nvPr/>
-        </p:nvSpPr>
-        <p:spPr>
-          <a:xfrm>
-            <a:off x="736092" y="4389627"/>
+          <p:cNvPr id="14" name="TextBox 13"/>
+          <p:cNvSpPr txBox="1"/>
+          <p:nvPr/>
+        </p:nvSpPr>
+        <p:spPr>
+          <a:xfrm>
+            <a:off x="736092" y="4401311"/>
             <a:ext cx="237744" cy="348488"/>
           </a:xfrm>
           <a:prstGeom prst="rect">
@@ -29044,37 +29082,37 @@
       </p:sp>
       <p:sp>
         <p:nvSpPr>
-          <p:cNvPr id="18" name="TextBox 17"/>
-          <p:cNvSpPr txBox="1"/>
-          <p:nvPr/>
-        </p:nvSpPr>
-        <p:spPr>
-          <a:xfrm>
-            <a:off x="1143000" y="4339335"/>
-            <a:ext cx="3054096" cy="820927"/>
-          </a:xfrm>
-          <a:prstGeom prst="rect">
-            <a:avLst/>
-          </a:prstGeom>
-          <a:noFill/>
-        </p:spPr>
-        <p:txBody>
-          <a:bodyPr wrap="none" lIns="0" rIns="0" tIns="0" bIns="0">
-            <a:spAutoFit/>
-          </a:bodyPr>
-          <a:lstStyle/>
-          <a:p>
-            <a:pPr>
-              <a:lnSpc>
-                <a:spcPct val="124000"/>
-              </a:lnSpc>
-              <a:spcBef>
-                <a:spcPts val="0"/>
-              </a:spcBef>
-              <a:spcAft>
-                <a:spcPts val="0"/>
-              </a:spcAft>
-              <a:defRPr sz="2200" b="0">
+          <p:cNvPr id="15" name="TextBox 14"/>
+          <p:cNvSpPr txBox="1"/>
+          <p:nvPr/>
+        </p:nvSpPr>
+        <p:spPr>
+          <a:xfrm>
+            <a:off x="1143000" y="4351020"/>
+            <a:ext cx="10387584" cy="584707"/>
+          </a:xfrm>
+          <a:prstGeom prst="rect">
+            <a:avLst/>
+          </a:prstGeom>
+          <a:noFill/>
+        </p:spPr>
+        <p:txBody>
+          <a:bodyPr wrap="none" lIns="0" rIns="0" tIns="0" bIns="0">
+            <a:spAutoFit/>
+          </a:bodyPr>
+          <a:lstStyle/>
+          <a:p>
+            <a:pPr>
+              <a:lnSpc>
+                <a:spcPct val="124000"/>
+              </a:lnSpc>
+              <a:spcBef>
+                <a:spcPts val="0"/>
+              </a:spcBef>
+              <a:spcAft>
+                <a:spcPts val="0"/>
+              </a:spcAft>
+              <a:defRPr sz="2900" b="0">
                 <a:solidFill>
                   <a:srgbClr val="131D2A"/>
                 </a:solidFill>
@@ -29082,112 +29120,14 @@
               </a:defRPr>
             </a:pPr>
             <a:r>
-              <a:t>Run the smoke test;</a:t>
-            </a:r>
-          </a:p>
-          <a:p>
-            <a:pPr>
-              <a:lnSpc>
-                <a:spcPct val="124000"/>
-              </a:lnSpc>
-              <a:spcBef>
-                <a:spcPts val="0"/>
-              </a:spcBef>
-              <a:spcAft>
-                <a:spcPts val="0"/>
-              </a:spcAft>
-              <a:defRPr sz="2200" b="0">
-                <a:solidFill>
-                  <a:srgbClr val="131D2A"/>
-                </a:solidFill>
-                <a:latin typeface="DejaVu Sans"/>
-              </a:defRPr>
-            </a:pPr>
-            <a:r>
-              <a:t>open results/live</a:t>
-            </a:r>
-          </a:p>
-        </p:txBody>
-      </p:sp>
-      <p:sp>
-        <p:nvSpPr>
-          <p:cNvPr id="19" name="Rounded Rectangle 18"/>
-          <p:cNvSpPr/>
-          <p:nvPr/>
-        </p:nvSpPr>
-        <p:spPr>
-          <a:xfrm>
-            <a:off x="594360" y="5559552"/>
-            <a:ext cx="11000232" cy="438912"/>
-          </a:xfrm>
-          <a:prstGeom prst="roundRect">
-            <a:avLst>
-              <a:gd name="adj" fmla="val 8000"/>
-            </a:avLst>
-          </a:prstGeom>
-          <a:solidFill>
-            <a:srgbClr val="131D2A"/>
-          </a:solidFill>
-          <a:ln>
-            <a:noFill/>
-          </a:ln>
-        </p:spPr>
-        <p:txBody>
-          <a:bodyPr rtlCol="0" anchor="ctr"/>
-          <a:lstStyle/>
-          <a:p>
-            <a:pPr algn="ctr"/>
-          </a:p>
-        </p:txBody>
-      </p:sp>
-      <p:sp>
-        <p:nvSpPr>
-          <p:cNvPr id="20" name="TextBox 19"/>
-          <p:cNvSpPr txBox="1"/>
-          <p:nvPr/>
-        </p:nvSpPr>
-        <p:spPr>
-          <a:xfrm>
-            <a:off x="777240" y="5650992"/>
-            <a:ext cx="10753344" cy="411480"/>
-          </a:xfrm>
-          <a:prstGeom prst="rect">
-            <a:avLst/>
-          </a:prstGeom>
-          <a:noFill/>
-        </p:spPr>
-        <p:txBody>
-          <a:bodyPr wrap="none" lIns="0" rIns="0" tIns="0" bIns="0">
-            <a:spAutoFit/>
-          </a:bodyPr>
-          <a:lstStyle/>
-          <a:p>
-            <a:pPr>
-              <a:lnSpc>
-                <a:spcPct val="124000"/>
-              </a:lnSpc>
-              <a:spcBef>
-                <a:spcPts val="0"/>
-              </a:spcBef>
-              <a:spcAft>
-                <a:spcPts val="0"/>
-              </a:spcAft>
-              <a:defRPr sz="1800" b="0">
-                <a:solidFill>
-                  <a:srgbClr val="FFFFFF"/>
-                </a:solidFill>
-                <a:latin typeface="DejaVu Sans Mono"/>
-              </a:defRPr>
-            </a:pPr>
-            <a:r>
-              <a:t>$ uv run --frozen python scripts/smoke_test.py</a:t>
-            </a:r>
-          </a:p>
-        </p:txBody>
-      </p:sp>
-      <p:sp>
-        <p:nvSpPr>
-          <p:cNvPr id="21" name="Rectangle 20"/>
+              <a:t>Run the scenario → inspect vx and x</a:t>
+            </a:r>
+          </a:p>
+        </p:txBody>
+      </p:sp>
+      <p:sp>
+        <p:nvSpPr>
+          <p:cNvPr id="16" name="Rectangle 15"/>
           <p:cNvSpPr/>
           <p:nvPr/>
         </p:nvSpPr>
@@ -29216,7 +29156,7 @@
       </p:sp>
       <p:sp>
         <p:nvSpPr>
-          <p:cNvPr id="22" name="TextBox 21"/>
+          <p:cNvPr id="17" name="TextBox 16"/>
           <p:cNvSpPr txBox="1"/>
           <p:nvPr/>
         </p:nvSpPr>
@@ -29254,15 +29194,15 @@
               </a:defRPr>
             </a:pPr>
             <a:r>
-              <a:t>WORKSHOP PASS · model editor ready</a:t>
-            </a:r>
-          </a:p>
-        </p:txBody>
-      </p:sp>
-      <p:sp>
-        <p:nvSpPr>
-          <p:cNvPr id="23" name="Rounded Rectangle 22">
-            <a:hlinkClick r:id="rId3"/>
+              <a:t>Modelica owns physics · TOML owns the run configuration.</a:t>
+            </a:r>
+          </a:p>
+        </p:txBody>
+      </p:sp>
+      <p:sp>
+        <p:nvSpPr>
+          <p:cNvPr id="18" name="Rounded Rectangle 17">
+            <a:hlinkClick r:id="rId2"/>
           </p:cNvPr>
           <p:cNvSpPr/>
           <p:nvPr/>
@@ -29294,8 +29234,8 @@
       </p:sp>
       <p:sp>
         <p:nvSpPr>
-          <p:cNvPr id="24" name="TextBox 23">
-            <a:hlinkClick r:id="rId3"/>
+          <p:cNvPr id="19" name="TextBox 18">
+            <a:hlinkClick r:id="rId2"/>
           </p:cNvPr>
           <p:cNvSpPr txBox="1"/>
           <p:nvPr/>
@@ -29334,15 +29274,15 @@
               </a:defRPr>
             </a:pPr>
             <a:r>
-              <a:t>Open vehicle model ↗</a:t>
-            </a:r>
-          </a:p>
-        </p:txBody>
-      </p:sp>
-      <p:sp>
-        <p:nvSpPr>
-          <p:cNvPr id="25" name="Rounded Rectangle 24">
-            <a:hlinkClick r:id="rId4"/>
+              <a:t>Simulation walkthrough ↗</a:t>
+            </a:r>
+          </a:p>
+        </p:txBody>
+      </p:sp>
+      <p:sp>
+        <p:nvSpPr>
+          <p:cNvPr id="20" name="Rounded Rectangle 19">
+            <a:hlinkClick r:id="rId3"/>
           </p:cNvPr>
           <p:cNvSpPr/>
           <p:nvPr/>
@@ -29374,8 +29314,8 @@
       </p:sp>
       <p:sp>
         <p:nvSpPr>
-          <p:cNvPr id="26" name="TextBox 25">
-            <a:hlinkClick r:id="rId4"/>
+          <p:cNvPr id="21" name="TextBox 20">
+            <a:hlinkClick r:id="rId3"/>
           </p:cNvPr>
           <p:cNvSpPr txBox="1"/>
           <p:nvPr/>
@@ -29414,14 +29354,14 @@
               </a:defRPr>
             </a:pPr>
             <a:r>
-              <a:t>Setup guide ↗</a:t>
-            </a:r>
-          </a:p>
-        </p:txBody>
-      </p:sp>
-      <p:sp>
-        <p:nvSpPr>
-          <p:cNvPr id="27" name="TextBox 26"/>
+              <a:t>Scenario model ↗</a:t>
+            </a:r>
+          </a:p>
+        </p:txBody>
+      </p:sp>
+      <p:sp>
+        <p:nvSpPr>
+          <p:cNvPr id="22" name="TextBox 21"/>
           <p:cNvSpPr txBox="1"/>
           <p:nvPr/>
         </p:nvSpPr>

</xml_diff>

<commit_message>
Show Cerebri deployment and runnable FastDyn instructions in the slides
</commit_message>
<xml_diff>
--- a/slides/workshop.pptx
+++ b/slides/workshop.pptx
@@ -1959,7 +1959,7 @@
           </a:p>
           <a:p>
             <a:r>
-              <a:t>Credit Arslan Khan’s group at Penn State and the Penn State/Purdue collaboration. Cite Muhammad Hammad Bashir, Michael Rooney, Colin Smith, Dongyan Xu and Arslan Khan, “BoardRunner: Automatic Firmware Rehosting using High-Fidelity Compositional Device Models,” ACM CCS 2026. The accepted-paper program verifies the title and authors: https://www.sigsac.org/ccs/CCS2026/program/accepted-papers.html. BoardRunner is the firmware-rehosting work; the Rumoca/FMI coupling and workshop campaign are integration examples, not results attributed to that paper. Follow the loop: firmware actuator command → FMU motor/rigid-body dynamics → simulated sensor values → firmware. This executes a rehosted hardware firmware binary, rather than ArduPilot SITL. The optional FastDyn configuration uses its own pinned Rumoca 0.10.0, separate from the workshop Python 0.10.2. The three-run example holds the vehicle, gains and mission fixed, applies prescribed external payload weight at a motor, and records seed, sources, telemetry, completion and failure reasons. It does not change inertial mass or simulate swinging payload motion. Three samples do not estimate rare-event probabilities or establish safety. See FASTDYN.md for current qualification status and the recorded upstream fallback. Main workshop remains model → simulate → identify → optimize. Solver specialization, heterogeneous compute, batched Monte Carlo/RL and extensible AD targets remain research directions.</a:t>
+              <a:t>Credit Arslan Khan’s group at Penn State and the Penn State/Purdue collaboration. Cite Muhammad Hammad Bashir, Michael Rooney, Colin Smith, Dongyan Xu and Arslan Khan, “BoardRunner: Automatic Firmware Rehosting using High-Fidelity Compositional Device Models,” ACM CCS 2026. The accepted-paper program verifies the title and authors: https://www.sigsac.org/ccs/CCS2026/program/accepted-papers.html. BoardRunner is the firmware-rehosting work; the Rumoca/FMI coupling and workshop campaign are integration examples, not results attributed to that paper. Follow the loop: firmware actuator command → FMU motor/rigid-body dynamics → simulated sensor values → firmware. This executes a rehosted hardware firmware binary, rather than ArduPilot SITL. The optional FastDyn configuration uses its own pinned Rumoca 0.10.0, separate from the workshop Python 0.10.2. The three-run example holds the vehicle, gains and mission fixed, applies prescribed external payload weight at a motor, and records seed, sources, telemetry, completion and failure reasons. It does not change inertial mass or simulate swinging payload motion. Three samples do not estimate rare-event probabilities or establish safety. Launch from https://github.com/codespaces/new/CogniPilot/rumoca_workshop_amc2026 using New with options and select FastDyn + Rumoca: optional firmware Monte Carlo, rather than the default core configuration. Then run the displayed command in its VS Code terminal, or select Terminal → Run Task → Workshop: optional FastDyn Monte Carlo. Open results/live/fastdyn/trajectories.png and compare the three flights; seed, sources, firmware logs and outcome summaries are retained. The pinned optional environment was created and the reference, 100 g endpoint and one seeded 87.7 g trial all completed the mission and landing in an actual two-core Codespace, taking about 74, 68 and 61 seconds after setup. Show the saved plot if the network is slow. See docs/FASTDYN.md for setup, storage and scope. Main workshop remains model → simulate → identify → optimize. Solver specialization, heterogeneous compute, batched Monte Carlo/RL and extensible AD targets remain research directions.</a:t>
             </a:r>
           </a:p>
         </p:txBody>
@@ -2109,7 +2109,7 @@
           </a:p>
           <a:p>
             <a:r>
-              <a:t>Ask first: “How many versions of the same physics do you maintain?” Independently maintained simulation, fitting and control models drift apart. The payoff is a shared source that lets us compare tools without silently changing the plant. Attendees bring Modelica knowledge and models from domains beyond aerospace; that breadth is valuable to the research community. We are building a unified, declarative modeling and simulation environment for cyberphysical systems. Modelica expresses physical intent as equations, so execution choices can change without rewriting that intent. We want declared physics and mathematical structure to travel across computational tools, so we can inspect equations, compare implementations and check assumptions. Rumoca is our open Modelica compiler for this workflow. Explain our broader uses in plain language: Lie group theory keeps rotations and rigid-body motion geometrically structured; reachable-set computation asks which states may be possible under bounded initial conditions and disturbances; formal software verification connects specified properties to proof obligations; system identification and digital twins connect models with measured behavior and experiments. The CogniPilot modelica_models library includes LieGroups SO(2), SO(3), SE(2), SE(3), SE_2(3), geometric estimation/control, and pure functions intended for verification and reachable-set propagation. These functions are building blocks, not complete safety certificates. Today uses a compact planar model, synthetic data, JAX fitting, CasADi trajectory optimization and a scoped Lean companion proof. It does not demonstrate a full Lie-group vehicle, compute a reachable tube, certify generated machine code or validate a physical digital twin. References: https://github.com/CogniPilot/modelica_models; Solà, Deray and Atchuthan, A micro Lie theory for state estimation in robotics, https://arxiv.org/abs/1812.01537; Althoff, Frehse and Girard, Set Propagation Techniques for Reachability Analysis, https://doi.org/10.1146/annurev-control-071420-081941. These support the mathematical ideas, not a claim that Rumoca implements every cited algorithm. Welcome questions from any discipline; the workshop needs no aerospace background.</a:t>
+              <a:t>Ask first: “How many versions of the same physics do you maintain?” Independently maintained simulation, fitting and control models drift apart. The payoff is a shared source that lets us compare tools without silently changing the plant. Attendees bring Modelica knowledge and models from domains beyond aerospace; that breadth is valuable to the research community. We are building a unified, declarative modeling and simulation environment for cyberphysical systems. Modelica expresses physical intent as equations, so execution choices can change without rewriting that intent. We want declared physics and mathematical structure to travel across computational tools, so we can inspect equations, compare implementations and check assumptions. Rumoca is our open Modelica compiler for this workflow. Explain our broader uses in plain language: Lie group theory keeps rotations and rigid-body motion geometrically structured; reachable-set computation asks which states may be possible under bounded initial conditions and disturbances; formal software verification connects specified properties to proof obligations; system identification and digital twins connect models with measured behavior and experiments. The CogniPilot modelica_models library includes LieGroups SO(2), SO(3), SE(2), SE(3), SE_2(3), geometric estimation/control, and pure functions intended for verification and reachable-set propagation. These functions are building blocks, not complete safety certificates. Show the Cerebri RDD2 deployment strip: our Zephyr-based autopilot takes Modelica controllers and estimation through Rumoca eFMI Production Code to C running on a real drone. Its current documented path is CRSF → generated control/estimation → quad-X mixer → DSHOT, with ACRO and AUTO_LEVEL modes. The build generates Vehicles.Rdd2.Controller and Estimation.ComplementaryAttitude from the shared modelica_models library. Source: https://github.com/CogniPilot/cerebri_rdd2. Mathematical guarantees must name a property and its assumptions; carrying verified model/controller properties through code generation, scheduling, sensors and actuators is a research goal. Neither eFMI generation nor this workshop’s planar-model proofs certify the complete Cerebri firmware, Zephyr RTOS or physical flight. Fast Monte Carlo/RL, native AD and heterogeneous compute remain further research directions. Today uses a compact planar model, synthetic data, JAX fitting, CasADi trajectory optimization and a scoped Lean companion proof. It does not demonstrate a full Lie-group vehicle, compute a reachable tube, certify generated machine code or validate a physical digital twin. References: https://github.com/CogniPilot/modelica_models; Solà, Deray and Atchuthan, A micro Lie theory for state estimation in robotics, https://arxiv.org/abs/1812.01537; Althoff, Frehse and Girard, Set Propagation Techniques for Reachability Analysis, https://doi.org/10.1146/annurev-control-071420-081941. These support the mathematical ideas, not a claim that Rumoca implements every cited algorithm. Welcome questions from any discipline; the workshop needs no aerospace background.</a:t>
             </a:r>
           </a:p>
         </p:txBody>
@@ -2184,7 +2184,7 @@
           </a:p>
           <a:p>
             <a:r>
-              <a:t>Explain that VS Code is the authoring/LSP path and the playground is browser modeling/simulation. Python 0.10.2 exports JAX and CasADi; deployed browser 0.8.13 is separate. Open examples/simulate.py and point to rm.Session().load(...) then model.to_jax(); open examples/optimize_casadi.py and point to model.to_casadi(). Python code performs integration and builds optimization objectives, not another plant. Full language/backends are not certified by this example. The compiler structure is an extension seam for solver specialization and heterogeneous compute. Fast Monte Carlo and RL, native AD or JAX/CasADi/PyTorch integrations, and extensible targets are research directions. Today's core qualifies particular CPU exports; the guide and small Torch target are separate demonstrations, not a general hardware-partitioning or throughput claim.</a:t>
+              <a:t>Explain that VS Code is the authoring/LSP path and the playground is browser modeling/simulation. Python 0.10.2 exports JAX and CasADi; deployed browser 0.8.13 is separate. Open examples/simulate.py and point to rum.Session().load(...) then model.to_jax(); open examples/optimize_casadi.py and point to model.to_casadi(). Python code performs integration and builds optimization objectives, not another plant. Full language/backends are not certified by this example. The compiler structure is an extension seam for solver specialization and heterogeneous compute. Fast Monte Carlo and RL, native AD or JAX/CasADi/PyTorch integrations, and extensible targets are research directions. Today's core qualifies particular CPU exports; the guide and small Torch target are separate demonstrations, not a general hardware-partitioning or throughput claim.</a:t>
             </a:r>
           </a:p>
         </p:txBody>
@@ -23421,7 +23421,7 @@
               </a:defRPr>
             </a:pPr>
             <a:r>
-              <a:t>Optional: three load trials,</a:t>
+              <a:t>New with options → select</a:t>
             </a:r>
           </a:p>
           <a:p>
@@ -23443,7 +23443,7 @@
               </a:defRPr>
             </a:pPr>
             <a:r>
-              <a:t>isolated logs and</a:t>
+              <a:t>FastDyn + Rumoca. Run</a:t>
             </a:r>
           </a:p>
           <a:p>
@@ -23465,7 +23465,7 @@
               </a:defRPr>
             </a:pPr>
             <a:r>
-              <a:t>trajectory comparisons.</a:t>
+              <a:t>three load trials.</a:t>
             </a:r>
           </a:p>
         </p:txBody>
@@ -23501,7 +23501,83 @@
       </p:sp>
       <p:sp>
         <p:nvSpPr>
-          <p:cNvPr id="23" name="Rectangle 22"/>
+          <p:cNvPr id="23" name="Rounded Rectangle 22"/>
+          <p:cNvSpPr/>
+          <p:nvPr/>
+        </p:nvSpPr>
+        <p:spPr>
+          <a:xfrm>
+            <a:off x="594360" y="5559552"/>
+            <a:ext cx="11000232" cy="438912"/>
+          </a:xfrm>
+          <a:prstGeom prst="roundRect">
+            <a:avLst>
+              <a:gd name="adj" fmla="val 8000"/>
+            </a:avLst>
+          </a:prstGeom>
+          <a:solidFill>
+            <a:srgbClr val="131D2A"/>
+          </a:solidFill>
+          <a:ln>
+            <a:noFill/>
+          </a:ln>
+        </p:spPr>
+        <p:txBody>
+          <a:bodyPr rtlCol="0" anchor="ctr"/>
+          <a:lstStyle/>
+          <a:p>
+            <a:pPr algn="ctr"/>
+          </a:p>
+        </p:txBody>
+      </p:sp>
+      <p:sp>
+        <p:nvSpPr>
+          <p:cNvPr id="24" name="TextBox 23"/>
+          <p:cNvSpPr txBox="1"/>
+          <p:nvPr/>
+        </p:nvSpPr>
+        <p:spPr>
+          <a:xfrm>
+            <a:off x="777240" y="5650992"/>
+            <a:ext cx="10753344" cy="411480"/>
+          </a:xfrm>
+          <a:prstGeom prst="rect">
+            <a:avLst/>
+          </a:prstGeom>
+          <a:noFill/>
+        </p:spPr>
+        <p:txBody>
+          <a:bodyPr wrap="none" lIns="0" rIns="0" tIns="0" bIns="0">
+            <a:spAutoFit/>
+          </a:bodyPr>
+          <a:lstStyle/>
+          <a:p>
+            <a:pPr>
+              <a:lnSpc>
+                <a:spcPct val="124000"/>
+              </a:lnSpc>
+              <a:spcBef>
+                <a:spcPts val="0"/>
+              </a:spcBef>
+              <a:spcAft>
+                <a:spcPts val="0"/>
+              </a:spcAft>
+              <a:defRPr sz="1800" b="0">
+                <a:solidFill>
+                  <a:srgbClr val="FFFFFF"/>
+                </a:solidFill>
+                <a:latin typeface="DejaVu Sans Mono"/>
+              </a:defRPr>
+            </a:pPr>
+            <a:r>
+              <a:t>$ uv run --frozen python scripts/fastdyn_demo.py</a:t>
+            </a:r>
+          </a:p>
+        </p:txBody>
+      </p:sp>
+      <p:sp>
+        <p:nvSpPr>
+          <p:cNvPr id="25" name="Rectangle 24"/>
           <p:cNvSpPr/>
           <p:nvPr/>
         </p:nvSpPr>
@@ -23530,7 +23606,7 @@
       </p:sp>
       <p:sp>
         <p:nvSpPr>
-          <p:cNvPr id="24" name="TextBox 23"/>
+          <p:cNvPr id="26" name="TextBox 25"/>
           <p:cNvSpPr txBox="1"/>
           <p:nvPr/>
         </p:nvSpPr>
@@ -23568,14 +23644,14 @@
               </a:defRPr>
             </a:pPr>
             <a:r>
-              <a:t>Separate FastDyn Codespace · keep the core setup lightweight.</a:t>
-            </a:r>
-          </a:p>
-        </p:txBody>
-      </p:sp>
-      <p:sp>
-        <p:nvSpPr>
-          <p:cNvPr id="25" name="Rounded Rectangle 24">
+              <a:t>Choose the FastDyn container · open results/live/fastdyn/trajectories.png</a:t>
+            </a:r>
+          </a:p>
+        </p:txBody>
+      </p:sp>
+      <p:sp>
+        <p:nvSpPr>
+          <p:cNvPr id="27" name="Rounded Rectangle 26">
             <a:hlinkClick r:id="rId2"/>
           </p:cNvPr>
           <p:cNvSpPr/>
@@ -23608,7 +23684,7 @@
       </p:sp>
       <p:sp>
         <p:nvSpPr>
-          <p:cNvPr id="26" name="TextBox 25">
+          <p:cNvPr id="28" name="TextBox 27">
             <a:hlinkClick r:id="rId2"/>
           </p:cNvPr>
           <p:cNvSpPr txBox="1"/>
@@ -23655,7 +23731,7 @@
       </p:sp>
       <p:sp>
         <p:nvSpPr>
-          <p:cNvPr id="27" name="Rounded Rectangle 26">
+          <p:cNvPr id="29" name="Rounded Rectangle 28">
             <a:hlinkClick r:id="rId3"/>
           </p:cNvPr>
           <p:cNvSpPr/>
@@ -23688,7 +23764,7 @@
       </p:sp>
       <p:sp>
         <p:nvSpPr>
-          <p:cNvPr id="28" name="TextBox 27">
+          <p:cNvPr id="30" name="TextBox 29">
             <a:hlinkClick r:id="rId3"/>
           </p:cNvPr>
           <p:cNvSpPr txBox="1"/>
@@ -23735,7 +23811,7 @@
       </p:sp>
       <p:sp>
         <p:nvSpPr>
-          <p:cNvPr id="29" name="Rounded Rectangle 28">
+          <p:cNvPr id="31" name="Rounded Rectangle 30">
             <a:hlinkClick r:id="rId4"/>
           </p:cNvPr>
           <p:cNvSpPr/>
@@ -23768,7 +23844,7 @@
       </p:sp>
       <p:sp>
         <p:nvSpPr>
-          <p:cNvPr id="30" name="TextBox 29">
+          <p:cNvPr id="32" name="TextBox 31">
             <a:hlinkClick r:id="rId4"/>
           </p:cNvPr>
           <p:cNvSpPr txBox="1"/>
@@ -23815,7 +23891,7 @@
       </p:sp>
       <p:sp>
         <p:nvSpPr>
-          <p:cNvPr id="31" name="TextBox 30"/>
+          <p:cNvPr id="33" name="TextBox 32"/>
           <p:cNvSpPr txBox="1"/>
           <p:nvPr/>
         </p:nvSpPr>
@@ -25366,30 +25442,30 @@
         <p:spPr>
           <a:xfrm>
             <a:off x="640080" y="5577840"/>
-            <a:ext cx="10936224" cy="379984"/>
-          </a:xfrm>
-          <a:prstGeom prst="rect">
-            <a:avLst/>
-          </a:prstGeom>
-          <a:noFill/>
-        </p:spPr>
-        <p:txBody>
-          <a:bodyPr wrap="none" lIns="0" rIns="0" tIns="0" bIns="0">
-            <a:spAutoFit/>
-          </a:bodyPr>
-          <a:lstStyle/>
-          <a:p>
-            <a:pPr>
-              <a:lnSpc>
-                <a:spcPct val="124000"/>
-              </a:lnSpc>
-              <a:spcBef>
-                <a:spcPts val="0"/>
-              </a:spcBef>
-              <a:spcAft>
-                <a:spcPts val="0"/>
-              </a:spcAft>
-              <a:defRPr sz="1600" b="0">
+            <a:ext cx="10936224" cy="427228"/>
+          </a:xfrm>
+          <a:prstGeom prst="rect">
+            <a:avLst/>
+          </a:prstGeom>
+          <a:noFill/>
+        </p:spPr>
+        <p:txBody>
+          <a:bodyPr wrap="none" lIns="0" rIns="0" tIns="0" bIns="0">
+            <a:spAutoFit/>
+          </a:bodyPr>
+          <a:lstStyle/>
+          <a:p>
+            <a:pPr>
+              <a:lnSpc>
+                <a:spcPct val="124000"/>
+              </a:lnSpc>
+              <a:spcBef>
+                <a:spcPts val="0"/>
+              </a:spcBef>
+              <a:spcAft>
+                <a:spcPts val="0"/>
+              </a:spcAft>
+              <a:defRPr sz="1900" b="1">
                 <a:solidFill>
                   <a:srgbClr val="007E87"/>
                 </a:solidFill>
@@ -25397,7 +25473,7 @@
               </a:defRPr>
             </a:pPr>
             <a:r>
-              <a:t>Research directions: fast Monte Carlo / RL · native AD · heterogeneous compute</a:t>
+              <a:t>Cerebri RDD2: Modelica → eFMI C → Zephyr RTOS → real drone</a:t>
             </a:r>
           </a:p>
         </p:txBody>
@@ -25440,30 +25516,30 @@
         <p:spPr>
           <a:xfrm>
             <a:off x="777240" y="6099048"/>
-            <a:ext cx="10872216" cy="411480"/>
-          </a:xfrm>
-          <a:prstGeom prst="rect">
-            <a:avLst/>
-          </a:prstGeom>
-          <a:noFill/>
-        </p:spPr>
-        <p:txBody>
-          <a:bodyPr wrap="none" lIns="0" rIns="0" tIns="0" bIns="0">
-            <a:spAutoFit/>
-          </a:bodyPr>
-          <a:lstStyle/>
-          <a:p>
-            <a:pPr>
-              <a:lnSpc>
-                <a:spcPct val="124000"/>
-              </a:lnSpc>
-              <a:spcBef>
-                <a:spcPts val="0"/>
-              </a:spcBef>
-              <a:spcAft>
-                <a:spcPts val="0"/>
-              </a:spcAft>
-              <a:defRPr sz="1800" b="1">
+            <a:ext cx="10872216" cy="410859"/>
+          </a:xfrm>
+          <a:prstGeom prst="rect">
+            <a:avLst/>
+          </a:prstGeom>
+          <a:noFill/>
+        </p:spPr>
+        <p:txBody>
+          <a:bodyPr wrap="none" lIns="0" rIns="0" tIns="0" bIns="0">
+            <a:spAutoFit/>
+          </a:bodyPr>
+          <a:lstStyle/>
+          <a:p>
+            <a:pPr>
+              <a:lnSpc>
+                <a:spcPct val="124000"/>
+              </a:lnSpc>
+              <a:spcBef>
+                <a:spcPts val="0"/>
+              </a:spcBef>
+              <a:spcAft>
+                <a:spcPts val="0"/>
+              </a:spcAft>
+              <a:defRPr sz="1796" b="1">
                 <a:solidFill>
                   <a:srgbClr val="007E87"/>
                 </a:solidFill>
@@ -25471,7 +25547,7 @@
               </a:defRPr>
             </a:pPr>
             <a:r>
-              <a:t>Today: one Modelica model → simulation → identification → optimization.</a:t>
+              <a:t>Goal: mathematical guarantees for specified properties under explicit assumptions.</a:t>
             </a:r>
           </a:p>
         </p:txBody>
@@ -25487,7 +25563,7 @@
         <p:spPr>
           <a:xfrm>
             <a:off x="594360" y="6432804"/>
-            <a:ext cx="5303520" cy="365760"/>
+            <a:ext cx="3499104" cy="365760"/>
           </a:xfrm>
           <a:prstGeom prst="roundRect">
             <a:avLst>
@@ -25520,7 +25596,7 @@
         <p:spPr>
           <a:xfrm>
             <a:off x="704088" y="6469380"/>
-            <a:ext cx="5138928" cy="332740"/>
+            <a:ext cx="3334512" cy="332740"/>
           </a:xfrm>
           <a:prstGeom prst="rect">
             <a:avLst/>
@@ -25566,8 +25642,8 @@
         </p:nvSpPr>
         <p:spPr>
           <a:xfrm>
-            <a:off x="6007608" y="6432804"/>
-            <a:ext cx="5303520" cy="365760"/>
+            <a:off x="4203192" y="6432804"/>
+            <a:ext cx="3499104" cy="365760"/>
           </a:xfrm>
           <a:prstGeom prst="roundRect">
             <a:avLst>
@@ -25599,8 +25675,8 @@
         </p:nvSpPr>
         <p:spPr>
           <a:xfrm>
-            <a:off x="6117336" y="6469380"/>
-            <a:ext cx="5138928" cy="332740"/>
+            <a:off x="4312920" y="6469380"/>
+            <a:ext cx="3334512" cy="332740"/>
           </a:xfrm>
           <a:prstGeom prst="rect">
             <a:avLst/>
@@ -25638,7 +25714,87 @@
       </p:sp>
       <p:sp>
         <p:nvSpPr>
-          <p:cNvPr id="31" name="TextBox 30"/>
+          <p:cNvPr id="31" name="Rounded Rectangle 30">
+            <a:hlinkClick r:id="rId4"/>
+          </p:cNvPr>
+          <p:cNvSpPr/>
+          <p:nvPr/>
+        </p:nvSpPr>
+        <p:spPr>
+          <a:xfrm>
+            <a:off x="7812024" y="6432804"/>
+            <a:ext cx="3499104" cy="365760"/>
+          </a:xfrm>
+          <a:prstGeom prst="roundRect">
+            <a:avLst>
+              <a:gd name="adj" fmla="val 8000"/>
+            </a:avLst>
+          </a:prstGeom>
+          <a:solidFill>
+            <a:srgbClr val="007E87"/>
+          </a:solidFill>
+          <a:ln>
+            <a:noFill/>
+          </a:ln>
+        </p:spPr>
+        <p:txBody>
+          <a:bodyPr rtlCol="0" anchor="ctr"/>
+          <a:lstStyle/>
+          <a:p>
+            <a:pPr algn="ctr"/>
+          </a:p>
+        </p:txBody>
+      </p:sp>
+      <p:sp>
+        <p:nvSpPr>
+          <p:cNvPr id="32" name="TextBox 31">
+            <a:hlinkClick r:id="rId4"/>
+          </p:cNvPr>
+          <p:cNvSpPr txBox="1"/>
+          <p:nvPr/>
+        </p:nvSpPr>
+        <p:spPr>
+          <a:xfrm>
+            <a:off x="7921751" y="6469380"/>
+            <a:ext cx="3334512" cy="332740"/>
+          </a:xfrm>
+          <a:prstGeom prst="rect">
+            <a:avLst/>
+          </a:prstGeom>
+          <a:noFill/>
+        </p:spPr>
+        <p:txBody>
+          <a:bodyPr wrap="none" lIns="0" rIns="0" tIns="0" bIns="0">
+            <a:spAutoFit/>
+          </a:bodyPr>
+          <a:lstStyle/>
+          <a:p>
+            <a:pPr>
+              <a:lnSpc>
+                <a:spcPct val="124000"/>
+              </a:lnSpc>
+              <a:spcBef>
+                <a:spcPts val="0"/>
+              </a:spcBef>
+              <a:spcAft>
+                <a:spcPts val="0"/>
+              </a:spcAft>
+              <a:defRPr sz="1300" b="1">
+                <a:solidFill>
+                  <a:srgbClr val="FFFFFF"/>
+                </a:solidFill>
+                <a:latin typeface="DejaVu Sans"/>
+              </a:defRPr>
+            </a:pPr>
+            <a:r>
+              <a:t>Cerebri RDD2 ↗</a:t>
+            </a:r>
+          </a:p>
+        </p:txBody>
+      </p:sp>
+      <p:sp>
+        <p:nvSpPr>
+          <p:cNvPr id="33" name="TextBox 32"/>
           <p:cNvSpPr txBox="1"/>
           <p:nvPr/>
         </p:nvSpPr>

</xml_diff>